<commit_message>
chore: atualiza documentos para apresentacao final
</commit_message>
<xml_diff>
--- a/disciplinas/gcetens843-projeto-algoritmo-i/atividades/trabalhos/projeto-algoritmos/apresentacao-minhafila.pptx
+++ b/disciplinas/gcetens843-projeto-algoritmo-i/atividades/trabalhos/projeto-algoritmos/apresentacao-minhafila.pptx
@@ -3133,7 +3133,7 @@
               </a:defRPr>
             </a:pPr>
             <a:r>
-              <a:t>FilaClara</a:t>
+              <a:t>MinhaFila</a:t>
             </a:r>
           </a:p>
           <a:p>
@@ -3508,7 +3508,7 @@
               </a:defRPr>
             </a:pPr>
             <a:r>
-              <a:t>Nossa Solução: FilaClara</a:t>
+              <a:t>Nossa Solução: MinhaFila</a:t>
             </a:r>
           </a:p>
         </p:txBody>

</xml_diff>